<commit_message>
Rephrase observation notes due to GPU non-determinism and address stats as approximations instead
</commit_message>
<xml_diff>
--- a/docs/Allen_DATA_606_Capstone_Progress_Update.pptx
+++ b/docs/Allen_DATA_606_Capstone_Progress_Update.pptx
@@ -252,7 +252,7 @@
 (medium.en-FT)</c:v>
                   </c:pt>
                   <c:pt idx="2">
-                    <c:v>Our Fine-Tune
+                    <c:v>Our Fine-Tune†
 (small.en)</c:v>
                   </c:pt>
                 </c:lvl>
@@ -590,7 +590,7 @@
 (medium.en-FT)</c:v>
                   </c:pt>
                   <c:pt idx="2">
-                    <c:v>Our Fine-Tune
+                    <c:v>Our Fine-Tune†
 (small.en)</c:v>
                   </c:pt>
                 </c:lvl>
@@ -2687,7 +2687,7 @@
                 <a:ea typeface="Arial" pitchFamily="34" charset="-122"/>
                 <a:cs typeface="Arial" pitchFamily="34" charset="-120"/>
               </a:rPr>
-              <a:t>PROGRESS UPDATE  —  EDA COMPLETE  ·  MACHINE LEARNING IN PROGRESS</a:t>
+              <a:t>PROGRESS UPDATE  ·  EDA COMPLETE  ·  MACHINE LEARNING IN PROGRESS</a:t>
             </a:r>
             <a:endParaRPr lang="en-US" sz="1250" dirty="0"/>
           </a:p>
@@ -3026,7 +3026,7 @@
                 <a:ea typeface="Arial" pitchFamily="34" charset="-122"/>
                 <a:cs typeface="Arial" pitchFamily="34" charset="-120"/>
               </a:rPr>
-              <a:t>Promote the notebook’s training + evaluation loop into a reusable script — same pattern as the data-ingest CLI.</a:t>
+              <a:t>Promote the notebook’s training + evaluation loop into a reusable script, following the same pattern as the data-ingest CLI.</a:t>
             </a:r>
             <a:endParaRPr lang="en-US" sz="1000" dirty="0"/>
           </a:p>
@@ -4922,7 +4922,7 @@
                 <a:ea typeface="Arial" pitchFamily="34" charset="-122"/>
                 <a:cs typeface="Arial" pitchFamily="34" charset="-120"/>
               </a:rPr>
-              <a:t>Complete — key findings &amp; data readiness</a:t>
+              <a:t>Complete: key findings &amp; data readiness</a:t>
             </a:r>
             <a:endParaRPr lang="en-US" sz="1000" dirty="0"/>
           </a:p>
@@ -5774,7 +5774,7 @@
                 <a:ea typeface="Arial" pitchFamily="34" charset="-122"/>
                 <a:cs typeface="Arial" pitchFamily="34" charset="-120"/>
               </a:rPr>
-              <a:t>Goal: a prototype tool (Streamlit app) that transcribes real ATC audio and extracts structured operational information — for pilots and controllers, not just a transcript.</a:t>
+              <a:t>Goal: a prototype tool (Streamlit app) that transcribes real ATC audio and extracts structured operational information for pilots and controllers, not just a transcript.</a:t>
             </a:r>
             <a:endParaRPr lang="en-US" sz="1300" dirty="0"/>
           </a:p>
@@ -6635,7 +6635,7 @@
                 <a:ea typeface="Arial" pitchFamily="34" charset="-122"/>
                 <a:cs typeface="Arial" pitchFamily="34" charset="-120"/>
               </a:rPr>
-              <a:t>02.  EDA Results — Complete</a:t>
+              <a:t>02.  EDA Results: Complete</a:t>
             </a:r>
             <a:endParaRPr lang="en-US" sz="2800" dirty="0"/>
           </a:p>
@@ -7346,7 +7346,7 @@
                 <a:ea typeface="Arial" pitchFamily="34" charset="-122"/>
                 <a:cs typeface="Arial" pitchFamily="34" charset="-120"/>
               </a:rPr>
-              <a:t>Full ingestion → cleaning → feature-derivation pipeline is reusable (src/preprocessing/) and already exposed as a standalone CLI script — see slide 07.</a:t>
+              <a:t>Full ingestion → cleaning → feature-derivation pipeline is reusable (src/preprocessing/) and already exposed as a standalone CLI script (see slide 07).</a:t>
             </a:r>
             <a:endParaRPr lang="en-US" sz="1150" dirty="0"/>
           </a:p>
@@ -7495,7 +7495,7 @@
                 <a:ea typeface="Arial" pitchFamily="34" charset="-122"/>
                 <a:cs typeface="Arial" pitchFamily="34" charset="-120"/>
               </a:rPr>
-              <a:t>02.  Key Finding — The Acoustic Domain Gap</a:t>
+              <a:t>02.  Key Finding: The Acoustic Domain Gap</a:t>
             </a:r>
             <a:endParaRPr lang="en-US" sz="2800" dirty="0"/>
           </a:p>
@@ -7558,7 +7558,7 @@
                 <a:ea typeface="Arial" pitchFamily="34" charset="-122"/>
                 <a:cs typeface="Arial" pitchFamily="34" charset="-120"/>
               </a:rPr>
-              <a:t>Real ATC audio is measurably narrower-band than simulated audio — the acoustic fingerprint of a VHF radio channel, and a domain gap any model must account for.</a:t>
+              <a:t>Real ATC audio is measurably narrower-band than simulated audio, the acoustic fingerprint of a VHF radio channel and a domain gap any model must account for.</a:t>
             </a:r>
             <a:endParaRPr lang="en-US" sz="1150" dirty="0"/>
           </a:p>
@@ -7707,7 +7707,7 @@
                 <a:ea typeface="Arial" pitchFamily="34" charset="-122"/>
                 <a:cs typeface="Arial" pitchFamily="34" charset="-120"/>
               </a:rPr>
-              <a:t>02.  Key Finding — Vocabulary &amp; Phraseology</a:t>
+              <a:t>02.  Key Finding: Vocabulary &amp; Phraseology</a:t>
             </a:r>
             <a:endParaRPr lang="en-US" sz="2800" dirty="0"/>
           </a:p>
@@ -7919,7 +7919,7 @@
                 <a:ea typeface="Arial" pitchFamily="34" charset="-122"/>
                 <a:cs typeface="Arial" pitchFamily="34" charset="-120"/>
               </a:rPr>
-              <a:t>03.  ML Progress — Pipeline Tooling</a:t>
+              <a:t>03.  ML Progress: Pipeline Tooling</a:t>
             </a:r>
             <a:endParaRPr lang="en-US" sz="2800" dirty="0"/>
           </a:p>
@@ -8109,7 +8109,7 @@
                 <a:ea typeface="Arial" pitchFamily="34" charset="-122"/>
                 <a:cs typeface="Arial" pitchFamily="34" charset="-120"/>
               </a:rPr>
-              <a:t>Standalone CLI for data curation/ingest — no notebook memory overhead</a:t>
+              <a:t>Standalone CLI for data curation/ingest, with no notebook memory overhead</a:t>
             </a:r>
             <a:endParaRPr lang="en-US" sz="1050" dirty="0"/>
           </a:p>
@@ -8796,7 +8796,7 @@
         </p:nvGraphicFramePr>
         <p:xfrm>
           <a:off x="457200" y="1508760"/>
-          <a:ext cx="3931920" cy="2834640"/>
+          <a:ext cx="3931920" cy="2651760"/>
         </p:xfrm>
         <a:graphic xmlns:a="http://schemas.openxmlformats.org/drawingml/2006/main">
           <a:graphicData uri="http://schemas.openxmlformats.org/drawingml/2006/chart">
@@ -8812,7 +8812,7 @@
         </p:nvGraphicFramePr>
         <p:xfrm>
           <a:off x="4663440" y="1508760"/>
-          <a:ext cx="3931920" cy="2834640"/>
+          <a:ext cx="3931920" cy="2651760"/>
         </p:xfrm>
         <a:graphic xmlns:a="http://schemas.openxmlformats.org/drawingml/2006/main">
           <a:graphicData uri="http://schemas.openxmlformats.org/drawingml/2006/chart">
@@ -8828,8 +8828,8 @@
         </p:nvSpPr>
         <p:spPr>
           <a:xfrm>
-            <a:off x="457200" y="4434840"/>
-            <a:ext cx="8229600" cy="274320"/>
+            <a:off x="457200" y="4251960"/>
+            <a:ext cx="8229600" cy="384048"/>
           </a:xfrm>
           <a:prstGeom prst="rect">
             <a:avLst/>
@@ -8853,7 +8853,24 @@
                 <a:ea typeface="Arial" pitchFamily="34" charset="-122"/>
                 <a:cs typeface="Arial" pitchFamily="34" charset="-120"/>
               </a:rPr>
-              <a:t>*Baseline’s real-audio WER is dominated by two runaway-generation (hallucination) outliers — see next slide.</a:t>
+              <a:t>*Baseline’s real-audio WER is dominated by two runaway-generation (hallucination) outliers (see next slide).</a:t>
+            </a:r>
+            <a:endParaRPr lang="en-US" sz="1000" dirty="0"/>
+          </a:p>
+          <a:p>
+            <a:pPr algn="l" indent="0" marL="0">
+              <a:buNone/>
+            </a:pPr>
+            <a:r>
+              <a:rPr lang="en-US" sz="1000" i="1" dirty="0">
+                <a:solidFill>
+                  <a:srgbClr val="6B7A86"/>
+                </a:solidFill>
+                <a:latin typeface="Arial" pitchFamily="34" charset="0"/>
+                <a:ea typeface="Arial" pitchFamily="34" charset="-122"/>
+                <a:cs typeface="Arial" pitchFamily="34" charset="-120"/>
+              </a:rPr>
+              <a:t>†Our Fine-Tune’s figures are approximate: exact WER shifts by a few tenths of a point each time it’s retrained (GPU non-determinism).</a:t>
             </a:r>
             <a:endParaRPr lang="en-US" sz="1000" dirty="0"/>
           </a:p>
@@ -9002,7 +9019,7 @@
                 <a:ea typeface="Arial" pitchFamily="34" charset="-122"/>
                 <a:cs typeface="Arial" pitchFamily="34" charset="-120"/>
               </a:rPr>
-              <a:t>04.  ASR Prototype — Key Takeaways</a:t>
+              <a:t>04.  ASR Prototype: Key Takeaways</a:t>
             </a:r>
             <a:endParaRPr lang="en-US" sz="2800" dirty="0"/>
           </a:p>
@@ -9246,7 +9263,7 @@
                 <a:ea typeface="Arial" pitchFamily="34" charset="-122"/>
                 <a:cs typeface="Arial" pitchFamily="34" charset="-120"/>
               </a:rPr>
-              <a:t>The generic baseline repeats itself into a 150-word loop on some real-audio clips — a documented Whisper hallucination pattern, not a bug in our code.</a:t>
+              <a:t>The generic baseline repeats itself into a 150-word loop on some real-audio clips, a documented Whisper hallucination pattern, not a bug in our code.</a:t>
             </a:r>
             <a:endParaRPr lang="en-US" sz="1050" dirty="0"/>
           </a:p>
@@ -9490,7 +9507,7 @@
                 <a:ea typeface="Arial" pitchFamily="34" charset="-122"/>
                 <a:cs typeface="Arial" pitchFamily="34" charset="-120"/>
               </a:rPr>
-              <a:t>jacktol’s real-audio numbers carry an unverified train/test-overlap risk — flagged explicitly rather than presented as a clean win.</a:t>
+              <a:t>jacktol’s real-audio numbers carry an unverified train/test-overlap risk, flagged explicitly rather than presented as a clean win.</a:t>
             </a:r>
             <a:endParaRPr lang="en-US" sz="1050" dirty="0"/>
           </a:p>

</xml_diff>